<commit_message>
ENHANCE: Updated PPTX build to add Ui Iteraction part
</commit_message>
<xml_diff>
--- a/docs/auxilab_eval_harness.pptx
+++ b/docs/auxilab_eval_harness.pptx
@@ -3721,7 +3721,7 @@
                   <a:srgbClr val="00D4FF"/>
                 </a:solidFill>
               </a:rPr>
-              <a:t>auxilab-eval-harness — Production-Grade Evaluation Framework for AI Agents</a:t>
+              <a:t>auxilab-eval-harness — Evaluate AI Agents via CLI or Browser UI</a:t>
             </a:r>
           </a:p>
         </p:txBody>
@@ -3750,12 +3750,12 @@
           <a:p>
             <a:pPr algn="l"/>
             <a:r>
-              <a:rPr sz="1700" b="0">
+              <a:rPr sz="1600" b="0">
                 <a:solidFill>
                   <a:srgbClr val="CCDDEE"/>
                 </a:solidFill>
               </a:rPr>
-              <a:t>Define YAML test cases → run against any Python agent → get structured reports.</a:t>
+              <a:t>Define YAML test cases → run against any Python agent → get structured reports — CLI or browser.</a:t>
             </a:r>
           </a:p>
         </p:txBody>
@@ -3841,7 +3841,7 @@
                             <a:srgbClr val="CCDDEE"/>
                           </a:solidFill>
                         </a:rPr>
-                        <a:t>YAML test definitions</a:t>
+                        <a:t>Gradio Web UI</a:t>
                       </a:r>
                     </a:p>
                   </a:txBody>
@@ -3863,7 +3863,7 @@
                             <a:srgbClr val="CCDDEE"/>
                           </a:solidFill>
                         </a:rPr>
-                        <a:t>Inputs, expected outputs &amp; eval strategy in plain YAML</a:t>
+                        <a:t>Upload YAML, pick agent, click Run — no CLI needed. Download HTML report.</a:t>
                       </a:r>
                     </a:p>
                   </a:txBody>
@@ -3887,7 +3887,7 @@
                             <a:srgbClr val="CCDDEE"/>
                           </a:solidFill>
                         </a:rPr>
-                        <a:t>5 evaluator types</a:t>
+                        <a:t>YAML test definitions</a:t>
                       </a:r>
                     </a:p>
                   </a:txBody>
@@ -3909,7 +3909,7 @@
                             <a:srgbClr val="CCDDEE"/>
                           </a:solidFill>
                         </a:rPr>
-                        <a:t>exact · regex · json_schema · semantic · llm_judge</a:t>
+                        <a:t>Inputs, expected outputs &amp; eval strategy in plain YAML</a:t>
                       </a:r>
                     </a:p>
                   </a:txBody>
@@ -3933,7 +3933,7 @@
                             <a:srgbClr val="CCDDEE"/>
                           </a:solidFill>
                         </a:rPr>
-                        <a:t>3 export formats</a:t>
+                        <a:t>5 evaluator types</a:t>
                       </a:r>
                     </a:p>
                   </a:txBody>
@@ -3955,7 +3955,7 @@
                             <a:srgbClr val="CCDDEE"/>
                           </a:solidFill>
                         </a:rPr>
-                        <a:t>Interactive HTML report · JSON · CSV (Excel-ready)</a:t>
+                        <a:t>exact · regex · json_schema · semantic · llm_judge</a:t>
                       </a:r>
                     </a:p>
                   </a:txBody>
@@ -3979,7 +3979,7 @@
                             <a:srgbClr val="CCDDEE"/>
                           </a:solidFill>
                         </a:rPr>
-                        <a:t>Rich CLI</a:t>
+                        <a:t>3 export formats</a:t>
                       </a:r>
                     </a:p>
                   </a:txBody>
@@ -4001,7 +4001,7 @@
                             <a:srgbClr val="CCDDEE"/>
                           </a:solidFill>
                         </a:rPr>
-                        <a:t>Colorized pass/fail output with latency &amp; score tracking</a:t>
+                        <a:t>Interactive HTML report · JSON · CSV (Excel-ready)</a:t>
                       </a:r>
                     </a:p>
                   </a:txBody>
@@ -4025,7 +4025,7 @@
                             <a:srgbClr val="CCDDEE"/>
                           </a:solidFill>
                         </a:rPr>
-                        <a:t>History tracking</a:t>
+                        <a:t>Rich CLI</a:t>
                       </a:r>
                     </a:p>
                   </a:txBody>
@@ -4047,7 +4047,7 @@
                             <a:srgbClr val="CCDDEE"/>
                           </a:solidFill>
                         </a:rPr>
-                        <a:t>SQLite-backed run history for trend analysis</a:t>
+                        <a:t>Colorized pass/fail output with latency &amp; score tracking</a:t>
                       </a:r>
                     </a:p>
                   </a:txBody>
@@ -4263,6 +4263,21 @@
                   <a:srgbClr val="FFFFFF"/>
                 </a:solidFill>
               </a:rPr>
+              <a:t>· Gradio 6</a:t>
+            </a:r>
+          </a:p>
+          <a:p>
+            <a:pPr>
+              <a:spcBef>
+                <a:spcPts val="400"/>
+              </a:spcBef>
+            </a:pPr>
+            <a:r>
+              <a:rPr sz="1300">
+                <a:solidFill>
+                  <a:srgbClr val="FFFFFF"/>
+                </a:solidFill>
+              </a:rPr>
               <a:t>· Jinja2</a:t>
             </a:r>
           </a:p>
@@ -4469,7 +4484,7 @@
                   <a:srgbClr val="FFFFFF"/>
                 </a:solidFill>
               </a:rPr>
-              <a:t>Demo — See It In Action</a:t>
+              <a:t>Demo — Two Ways to Run</a:t>
             </a:r>
           </a:p>
         </p:txBody>
@@ -4503,198 +4518,21 @@
                   <a:srgbClr val="00D4FF"/>
                 </a:solidFill>
               </a:rPr>
-              <a:t>3-minute end-to-end walkthrough</a:t>
-            </a:r>
-          </a:p>
-        </p:txBody>
-      </p:sp>
-      <p:sp>
-        <p:nvSpPr>
-          <p:cNvPr id="6" name="TextBox 5"/>
-          <p:cNvSpPr txBox="1"/>
-          <p:nvPr/>
-        </p:nvSpPr>
-        <p:spPr>
-          <a:xfrm>
-            <a:off x="365760" y="1417320"/>
-            <a:ext cx="5303520" cy="365760"/>
-          </a:xfrm>
-          <a:prstGeom prst="rect">
-            <a:avLst/>
-          </a:prstGeom>
-          <a:noFill/>
-        </p:spPr>
-        <p:txBody>
-          <a:bodyPr wrap="square">
-            <a:spAutoFit/>
-          </a:bodyPr>
-          <a:lstStyle/>
-          <a:p>
-            <a:pPr algn="l"/>
-            <a:r>
-              <a:rPr sz="1500" b="1">
-                <a:solidFill>
-                  <a:srgbClr val="00D4FF"/>
-                </a:solidFill>
-              </a:rPr>
-              <a:t>Three commands to full report</a:t>
-            </a:r>
-          </a:p>
-        </p:txBody>
-      </p:sp>
-      <p:sp>
-        <p:nvSpPr>
-          <p:cNvPr id="7" name="TextBox 6"/>
-          <p:cNvSpPr txBox="1"/>
-          <p:nvPr/>
-        </p:nvSpPr>
-        <p:spPr>
-          <a:xfrm>
-            <a:off x="365760" y="1828800"/>
-            <a:ext cx="5120640" cy="4389120"/>
-          </a:xfrm>
-          <a:prstGeom prst="rect">
-            <a:avLst/>
-          </a:prstGeom>
-          <a:noFill/>
-        </p:spPr>
-        <p:txBody>
-          <a:bodyPr wrap="square">
-            <a:spAutoFit/>
-          </a:bodyPr>
-          <a:lstStyle/>
-          <a:p>
-            <a:pPr>
-              <a:spcBef>
-                <a:spcPts val="400"/>
-              </a:spcBef>
-            </a:pPr>
-            <a:r>
-              <a:rPr sz="1400">
-                <a:solidFill>
-                  <a:srgbClr val="FFFFFF"/>
-                </a:solidFill>
-              </a:rPr>
-              <a:t>1.  pip install -e .</a:t>
-            </a:r>
-          </a:p>
-          <a:p>
-            <a:pPr>
-              <a:spcBef>
-                <a:spcPts val="400"/>
-              </a:spcBef>
-            </a:pPr>
-            <a:r>
-              <a:rPr sz="1400">
-                <a:solidFill>
-                  <a:srgbClr val="FFFFFF"/>
-                </a:solidFill>
-              </a:rPr>
-              <a:t>      One-line install, no env hacks</a:t>
-            </a:r>
-          </a:p>
-          <a:p>
-            <a:pPr>
-              <a:spcBef>
-                <a:spcPts val="400"/>
-              </a:spcBef>
-            </a:pPr>
-            <a:r>
-              <a:rPr sz="1400">
-                <a:solidFill>
-                  <a:srgbClr val="FFFFFF"/>
-                </a:solidFill>
-              </a:rPr>
-              <a:t/>
-            </a:r>
-          </a:p>
-          <a:p>
-            <a:pPr>
-              <a:spcBef>
-                <a:spcPts val="400"/>
-              </a:spcBef>
-            </a:pPr>
-            <a:r>
-              <a:rPr sz="1400">
-                <a:solidFill>
-                  <a:srgbClr val="FFFFFF"/>
-                </a:solidFill>
-              </a:rPr>
-              <a:t>2.  python demo_all_features.py</a:t>
-            </a:r>
-          </a:p>
-          <a:p>
-            <a:pPr>
-              <a:spcBef>
-                <a:spcPts val="400"/>
-              </a:spcBef>
-            </a:pPr>
-            <a:r>
-              <a:rPr sz="1400">
-                <a:solidFill>
-                  <a:srgbClr val="FFFFFF"/>
-                </a:solidFill>
-              </a:rPr>
-              <a:t>      Runs 38 tests across 2 agents</a:t>
-            </a:r>
-          </a:p>
-          <a:p>
-            <a:pPr>
-              <a:spcBef>
-                <a:spcPts val="400"/>
-              </a:spcBef>
-            </a:pPr>
-            <a:r>
-              <a:rPr sz="1400">
-                <a:solidFill>
-                  <a:srgbClr val="FFFFFF"/>
-                </a:solidFill>
-              </a:rPr>
-              <a:t/>
-            </a:r>
-          </a:p>
-          <a:p>
-            <a:pPr>
-              <a:spcBef>
-                <a:spcPts val="400"/>
-              </a:spcBef>
-            </a:pPr>
-            <a:r>
-              <a:rPr sz="1400">
-                <a:solidFill>
-                  <a:srgbClr val="FFFFFF"/>
-                </a:solidFill>
-              </a:rPr>
-              <a:t>3.  Open reports/ap_exception_report.html</a:t>
-            </a:r>
-          </a:p>
-          <a:p>
-            <a:pPr>
-              <a:spcBef>
-                <a:spcPts val="400"/>
-              </a:spcBef>
-            </a:pPr>
-            <a:r>
-              <a:rPr sz="1400">
-                <a:solidFill>
-                  <a:srgbClr val="FFFFFF"/>
-                </a:solidFill>
-              </a:rPr>
-              <a:t>      Interactive HTML report in browser</a:t>
-            </a:r>
-          </a:p>
-        </p:txBody>
-      </p:sp>
-      <p:sp>
-        <p:nvSpPr>
-          <p:cNvPr id="8" name="Rectangle 7"/>
+              <a:t>Browser UI (no CLI needed)  |  CLI for power users &amp; CI/CD</a:t>
+            </a:r>
+          </a:p>
+        </p:txBody>
+      </p:sp>
+      <p:sp>
+        <p:nvSpPr>
+          <p:cNvPr id="6" name="Rectangle 5"/>
           <p:cNvSpPr/>
           <p:nvPr/>
         </p:nvSpPr>
         <p:spPr>
           <a:xfrm>
-            <a:off x="5760720" y="1371600"/>
-            <a:ext cx="25400" cy="5120640"/>
+            <a:off x="5989320" y="1371600"/>
+            <a:ext cx="25400" cy="5212080"/>
           </a:xfrm>
           <a:prstGeom prst="rect">
             <a:avLst/>
@@ -4730,14 +4568,14 @@
       </p:sp>
       <p:sp>
         <p:nvSpPr>
-          <p:cNvPr id="9" name="TextBox 8"/>
+          <p:cNvPr id="7" name="TextBox 6"/>
           <p:cNvSpPr txBox="1"/>
           <p:nvPr/>
         </p:nvSpPr>
         <p:spPr>
           <a:xfrm>
-            <a:off x="6035040" y="1417320"/>
-            <a:ext cx="5760720" cy="365760"/>
+            <a:off x="274320" y="1417320"/>
+            <a:ext cx="5486400" cy="365760"/>
           </a:xfrm>
           <a:prstGeom prst="rect">
             <a:avLst/>
@@ -4754,24 +4592,24 @@
             <a:r>
               <a:rPr sz="1500" b="1">
                 <a:solidFill>
-                  <a:srgbClr val="FFD700"/>
+                  <a:srgbClr val="00D4FF"/>
                 </a:solidFill>
               </a:rPr>
-              <a:t>CLI Output</a:t>
-            </a:r>
-          </a:p>
-        </p:txBody>
-      </p:sp>
-      <p:sp>
-        <p:nvSpPr>
-          <p:cNvPr id="10" name="TextBox 9"/>
+              <a:t>🖼️  Path A — Web UI</a:t>
+            </a:r>
+          </a:p>
+        </p:txBody>
+      </p:sp>
+      <p:sp>
+        <p:nvSpPr>
+          <p:cNvPr id="8" name="TextBox 7"/>
           <p:cNvSpPr txBox="1"/>
           <p:nvPr/>
         </p:nvSpPr>
         <p:spPr>
           <a:xfrm>
-            <a:off x="6035040" y="1828800"/>
-            <a:ext cx="5760720" cy="2103120"/>
+            <a:off x="274320" y="1874519"/>
+            <a:ext cx="5486400" cy="4663440"/>
           </a:xfrm>
           <a:prstGeom prst="rect">
             <a:avLst/>
@@ -4784,37 +4622,246 @@
           </a:bodyPr>
           <a:lstStyle/>
           <a:p>
-            <a:r>
-              <a:rPr sz="1100">
-                <a:solidFill>
-                  <a:srgbClr val="00E576"/>
-                </a:solidFill>
-                <a:latin typeface="Courier New"/>
+            <a:pPr>
+              <a:spcBef>
+                <a:spcPts val="400"/>
+              </a:spcBef>
+            </a:pPr>
+            <a:r>
+              <a:rPr sz="1300">
+                <a:solidFill>
+                  <a:srgbClr val="FFFFFF"/>
+                </a:solidFill>
               </a:rPr>
-              <a:t>╔════════════════════════════════╗
-║  Evaluation Complete           ║
-╚════════════════════════════════╝
-  ✓ Passed:    18 / 20
-  ✗ Failed:     2 / 20
-  Pass Rate:  🟢 90.0 %
-  Avg Score:    0.89
-  Avg Latency:  12.4 ms
-  Min Latency:   8.2 ms
-  Max Latency:  18.7 ms</a:t>
-            </a:r>
-          </a:p>
-        </p:txBody>
-      </p:sp>
-      <p:sp>
-        <p:nvSpPr>
-          <p:cNvPr id="11" name="Rectangle 10"/>
+              <a:t>1.  python app.py</a:t>
+            </a:r>
+          </a:p>
+          <a:p>
+            <a:pPr>
+              <a:spcBef>
+                <a:spcPts val="400"/>
+              </a:spcBef>
+            </a:pPr>
+            <a:r>
+              <a:rPr sz="1300">
+                <a:solidFill>
+                  <a:srgbClr val="FFFFFF"/>
+                </a:solidFill>
+              </a:rPr>
+              <a:t>      Opens http://127.0.0.1:7860</a:t>
+            </a:r>
+          </a:p>
+          <a:p>
+            <a:pPr>
+              <a:spcBef>
+                <a:spcPts val="400"/>
+              </a:spcBef>
+            </a:pPr>
+            <a:r>
+              <a:rPr sz="1300">
+                <a:solidFill>
+                  <a:srgbClr val="FFFFFF"/>
+                </a:solidFill>
+              </a:rPr>
+              <a:t/>
+            </a:r>
+          </a:p>
+          <a:p>
+            <a:pPr>
+              <a:spcBef>
+                <a:spcPts val="400"/>
+              </a:spcBef>
+            </a:pPr>
+            <a:r>
+              <a:rPr sz="1300">
+                <a:solidFill>
+                  <a:srgbClr val="FFFFFF"/>
+                </a:solidFill>
+              </a:rPr>
+              <a:t>2.  Upload .yaml test file</a:t>
+            </a:r>
+          </a:p>
+          <a:p>
+            <a:pPr>
+              <a:spcBef>
+                <a:spcPts val="400"/>
+              </a:spcBef>
+            </a:pPr>
+            <a:r>
+              <a:rPr sz="1300">
+                <a:solidFill>
+                  <a:srgbClr val="FFFFFF"/>
+                </a:solidFill>
+              </a:rPr>
+              <a:t>      or click a built-in example</a:t>
+            </a:r>
+          </a:p>
+          <a:p>
+            <a:pPr>
+              <a:spcBef>
+                <a:spcPts val="400"/>
+              </a:spcBef>
+            </a:pPr>
+            <a:r>
+              <a:rPr sz="1300">
+                <a:solidFill>
+                  <a:srgbClr val="FFFFFF"/>
+                </a:solidFill>
+              </a:rPr>
+              <a:t/>
+            </a:r>
+          </a:p>
+          <a:p>
+            <a:pPr>
+              <a:spcBef>
+                <a:spcPts val="400"/>
+              </a:spcBef>
+            </a:pPr>
+            <a:r>
+              <a:rPr sz="1300">
+                <a:solidFill>
+                  <a:srgbClr val="FFFFFF"/>
+                </a:solidFill>
+              </a:rPr>
+              <a:t>3.  Select agent from dropdown</a:t>
+            </a:r>
+          </a:p>
+          <a:p>
+            <a:pPr>
+              <a:spcBef>
+                <a:spcPts val="400"/>
+              </a:spcBef>
+            </a:pPr>
+            <a:r>
+              <a:rPr sz="1300">
+                <a:solidFill>
+                  <a:srgbClr val="FFFFFF"/>
+                </a:solidFill>
+              </a:rPr>
+              <a:t>      Description shows required fields</a:t>
+            </a:r>
+          </a:p>
+          <a:p>
+            <a:pPr>
+              <a:spcBef>
+                <a:spcPts val="400"/>
+              </a:spcBef>
+            </a:pPr>
+            <a:r>
+              <a:rPr sz="1300">
+                <a:solidFill>
+                  <a:srgbClr val="FFFFFF"/>
+                </a:solidFill>
+              </a:rPr>
+              <a:t/>
+            </a:r>
+          </a:p>
+          <a:p>
+            <a:pPr>
+              <a:spcBef>
+                <a:spcPts val="400"/>
+              </a:spcBef>
+            </a:pPr>
+            <a:r>
+              <a:rPr sz="1300">
+                <a:solidFill>
+                  <a:srgbClr val="FFFFFF"/>
+                </a:solidFill>
+              </a:rPr>
+              <a:t>4.  Click  ▶ Run Evaluation</a:t>
+            </a:r>
+          </a:p>
+          <a:p>
+            <a:pPr>
+              <a:spcBef>
+                <a:spcPts val="400"/>
+              </a:spcBef>
+            </a:pPr>
+            <a:r>
+              <a:rPr sz="1300">
+                <a:solidFill>
+                  <a:srgbClr val="FFFFFF"/>
+                </a:solidFill>
+              </a:rPr>
+              <a:t/>
+            </a:r>
+          </a:p>
+          <a:p>
+            <a:pPr>
+              <a:spcBef>
+                <a:spcPts val="400"/>
+              </a:spcBef>
+            </a:pPr>
+            <a:r>
+              <a:rPr sz="1300">
+                <a:solidFill>
+                  <a:srgbClr val="FFFFFF"/>
+                </a:solidFill>
+              </a:rPr>
+              <a:t>5.  📥 Download HTML Report button</a:t>
+            </a:r>
+          </a:p>
+          <a:p>
+            <a:pPr>
+              <a:spcBef>
+                <a:spcPts val="400"/>
+              </a:spcBef>
+            </a:pPr>
+            <a:r>
+              <a:rPr sz="1300">
+                <a:solidFill>
+                  <a:srgbClr val="FFFFFF"/>
+                </a:solidFill>
+              </a:rPr>
+              <a:t>      Same interactive report as CLI</a:t>
+            </a:r>
+          </a:p>
+        </p:txBody>
+      </p:sp>
+      <p:sp>
+        <p:nvSpPr>
+          <p:cNvPr id="9" name="TextBox 8"/>
+          <p:cNvSpPr txBox="1"/>
+          <p:nvPr/>
+        </p:nvSpPr>
+        <p:spPr>
+          <a:xfrm>
+            <a:off x="6172200" y="1417320"/>
+            <a:ext cx="5760720" cy="365760"/>
+          </a:xfrm>
+          <a:prstGeom prst="rect">
+            <a:avLst/>
+          </a:prstGeom>
+          <a:noFill/>
+        </p:spPr>
+        <p:txBody>
+          <a:bodyPr wrap="square">
+            <a:spAutoFit/>
+          </a:bodyPr>
+          <a:lstStyle/>
+          <a:p>
+            <a:pPr algn="l"/>
+            <a:r>
+              <a:rPr sz="1500" b="1">
+                <a:solidFill>
+                  <a:srgbClr val="FFD700"/>
+                </a:solidFill>
+              </a:rPr>
+              <a:t>🖥️  Path B — CLI</a:t>
+            </a:r>
+          </a:p>
+        </p:txBody>
+      </p:sp>
+      <p:sp>
+        <p:nvSpPr>
+          <p:cNvPr id="10" name="Rectangle 9"/>
           <p:cNvSpPr/>
           <p:nvPr/>
         </p:nvSpPr>
         <p:spPr>
           <a:xfrm>
-            <a:off x="6035040" y="1828800"/>
-            <a:ext cx="5760720" cy="2103120"/>
+            <a:off x="6172200" y="1874519"/>
+            <a:ext cx="5760720" cy="1920240"/>
           </a:xfrm>
           <a:prstGeom prst="rect">
             <a:avLst/>
@@ -4850,14 +4897,14 @@
       </p:sp>
       <p:sp>
         <p:nvSpPr>
-          <p:cNvPr id="12" name="TextBox 11"/>
+          <p:cNvPr id="11" name="TextBox 10"/>
           <p:cNvSpPr txBox="1"/>
           <p:nvPr/>
         </p:nvSpPr>
         <p:spPr>
           <a:xfrm>
-            <a:off x="6035040" y="4069080"/>
-            <a:ext cx="5760720" cy="365760"/>
+            <a:off x="6263640" y="1920240"/>
+            <a:ext cx="5577840" cy="1828800"/>
           </a:xfrm>
           <a:prstGeom prst="rect">
             <a:avLst/>
@@ -4865,6 +4912,44 @@
           <a:noFill/>
         </p:spPr>
         <p:txBody>
+          <a:bodyPr wrap="none">
+            <a:spAutoFit/>
+          </a:bodyPr>
+          <a:lstStyle/>
+          <a:p>
+            <a:r>
+              <a:rPr sz="1100">
+                <a:solidFill>
+                  <a:srgbClr val="00E576"/>
+                </a:solidFill>
+                <a:latin typeface="Courier New"/>
+              </a:rPr>
+              <a:t>╔════════════════════════════════╗
+║  Evaluation Complete           ║
+╚════════════════════════════════╝
+  ✓ Passed:  18/20  🟢 90.0%
+  Avg Latency: 12.4 ms</a:t>
+            </a:r>
+          </a:p>
+        </p:txBody>
+      </p:sp>
+      <p:sp>
+        <p:nvSpPr>
+          <p:cNvPr id="12" name="TextBox 11"/>
+          <p:cNvSpPr txBox="1"/>
+          <p:nvPr/>
+        </p:nvSpPr>
+        <p:spPr>
+          <a:xfrm>
+            <a:off x="6172200" y="3931920"/>
+            <a:ext cx="5760720" cy="320040"/>
+          </a:xfrm>
+          <a:prstGeom prst="rect">
+            <a:avLst/>
+          </a:prstGeom>
+          <a:noFill/>
+        </p:spPr>
+        <p:txBody>
           <a:bodyPr wrap="square">
             <a:spAutoFit/>
           </a:bodyPr>
@@ -4872,12 +4957,12 @@
           <a:p>
             <a:pPr algn="l"/>
             <a:r>
-              <a:rPr sz="1400" b="1">
+              <a:rPr sz="1300" b="1">
                 <a:solidFill>
                   <a:srgbClr val="00D4FF"/>
                 </a:solidFill>
               </a:rPr>
-              <a:t>Add a test in 10 lines of YAML</a:t>
+              <a:t>Command:</a:t>
             </a:r>
           </a:p>
         </p:txBody>
@@ -4890,8 +4975,8 @@
         </p:nvSpPr>
         <p:spPr>
           <a:xfrm>
-            <a:off x="6035040" y="4480560"/>
-            <a:ext cx="5760720" cy="2103120"/>
+            <a:off x="6172200" y="4251960"/>
+            <a:ext cx="5760720" cy="1371600"/>
           </a:xfrm>
           <a:prstGeom prst="rect">
             <a:avLst/>
@@ -4933,8 +5018,8 @@
         </p:nvSpPr>
         <p:spPr>
           <a:xfrm>
-            <a:off x="6126480" y="4526280"/>
-            <a:ext cx="5577840" cy="2011680"/>
+            <a:off x="6263640" y="4297680"/>
+            <a:ext cx="5577840" cy="1280160"/>
           </a:xfrm>
           <a:prstGeom prst="rect">
             <a:avLst/>
@@ -4954,15 +5039,10 @@
                 </a:solidFill>
                 <a:latin typeface="Courier New"/>
               </a:rPr>
-              <a:t>- id: my_001_duplicate
-  input:
-    invoice_id: INV-9999
-    duplicate_of: INV-9998
-  expected:
-    decision: flag_duplicate
-  evaluators:
-    - type: exact
-      field: decision</a:t>
+              <a:t>auxilab-eval run \
+  --tests ap_tests.yaml \
+  --agent demo.agent:handle \
+  --html report.html</a:t>
             </a:r>
           </a:p>
         </p:txBody>
@@ -6577,7 +6657,7 @@
                   <a:srgbClr val="FFFFFF"/>
                 </a:solidFill>
               </a:rPr>
-              <a:t>▸ Gradio web UI — no CLI needed</a:t>
+              <a:t>▸ GitHub Actions workflow template</a:t>
             </a:r>
           </a:p>
           <a:p>
@@ -6592,7 +6672,7 @@
                   <a:srgbClr val="FFFFFF"/>
                 </a:solidFill>
               </a:rPr>
-              <a:t>▸ GitHub Actions workflow template</a:t>
+              <a:t>▸ Slack / email threshold alerts</a:t>
             </a:r>
           </a:p>
           <a:p>
@@ -6607,7 +6687,7 @@
                   <a:srgbClr val="FFFFFF"/>
                 </a:solidFill>
               </a:rPr>
-              <a:t>▸ Slack / email threshold alerts</a:t>
+              <a:t>▸ UI: side-by-side run comparison</a:t>
             </a:r>
           </a:p>
         </p:txBody>
@@ -6780,7 +6860,7 @@
                   <a:srgbClr val="FFFFFF"/>
                 </a:solidFill>
               </a:rPr>
-              <a:t>▸ Multi-run regression comparison</a:t>
+              <a:t>▸ Team dashboard with shared DB</a:t>
             </a:r>
           </a:p>
           <a:p>
@@ -6795,7 +6875,7 @@
                   <a:srgbClr val="FFFFFF"/>
                 </a:solidFill>
               </a:rPr>
-              <a:t>▸ Team dashboard with shared DB</a:t>
+              <a:t>▸ OpenAI &amp; other LLM judge backends</a:t>
             </a:r>
           </a:p>
           <a:p>
@@ -6810,7 +6890,7 @@
                   <a:srgbClr val="FFFFFF"/>
                 </a:solidFill>
               </a:rPr>
-              <a:t>▸ OpenAI &amp; other LLM judge backends</a:t>
+              <a:t>▸ UI: upload agent .py directly</a:t>
             </a:r>
           </a:p>
         </p:txBody>
@@ -7104,12 +7184,12 @@
           <a:p>
             <a:pPr algn="ctr"/>
             <a:r>
-              <a:rPr sz="1800" b="0">
+              <a:rPr sz="1700" b="0">
                 <a:solidFill>
                   <a:srgbClr val="00D4FF"/>
                 </a:solidFill>
               </a:rPr>
-              <a:t>pip install auxilab-eval   →   add your first test case in 5 minutes</a:t>
+              <a:t>python app.py   →   open http://127.0.0.1:7860   →   run your first evaluation in 2 minutes</a:t>
             </a:r>
           </a:p>
         </p:txBody>

</xml_diff>

<commit_message>
FEAT: Add demo video link in readme file and updated the ppt file
</commit_message>
<xml_diff>
--- a/docs/auxilab_eval_harness.pptx
+++ b/docs/auxilab_eval_harness.pptx
@@ -3543,6 +3543,350 @@
           <a:lstStyle/>
           <a:p>
             <a:pPr algn="ctr"/>
+          </a:p>
+        </p:txBody>
+      </p:sp>
+      <p:sp>
+        <p:nvSpPr>
+          <p:cNvPr id="12" name="Rectangle 11"/>
+          <p:cNvSpPr/>
+          <p:nvPr/>
+        </p:nvSpPr>
+        <p:spPr>
+          <a:xfrm>
+            <a:off x="9866376" y="51206"/>
+            <a:ext cx="2231136" cy="601675"/>
+          </a:xfrm>
+          <a:prstGeom prst="rect">
+            <a:avLst/>
+          </a:prstGeom>
+          <a:solidFill>
+            <a:srgbClr val="0D1B2A"/>
+          </a:solidFill>
+          <a:ln>
+            <a:noFill/>
+          </a:ln>
+        </p:spPr>
+        <p:style>
+          <a:lnRef idx="1">
+            <a:schemeClr val="accent1"/>
+          </a:lnRef>
+          <a:fillRef idx="3">
+            <a:schemeClr val="accent1"/>
+          </a:fillRef>
+          <a:effectRef idx="2">
+            <a:schemeClr val="accent1"/>
+          </a:effectRef>
+          <a:fontRef idx="minor">
+            <a:schemeClr val="lt1"/>
+          </a:fontRef>
+        </p:style>
+        <p:txBody>
+          <a:bodyPr rtlCol="0" anchor="ctr"/>
+          <a:lstStyle/>
+          <a:p>
+            <a:pPr algn="ctr"/>
+          </a:p>
+        </p:txBody>
+      </p:sp>
+      <p:sp>
+        <p:nvSpPr>
+          <p:cNvPr id="13" name="Rectangle 12"/>
+          <p:cNvSpPr/>
+          <p:nvPr/>
+        </p:nvSpPr>
+        <p:spPr>
+          <a:xfrm>
+            <a:off x="9866376" y="51206"/>
+            <a:ext cx="32004" cy="601675"/>
+          </a:xfrm>
+          <a:prstGeom prst="rect">
+            <a:avLst/>
+          </a:prstGeom>
+          <a:solidFill>
+            <a:srgbClr val="00D4FF"/>
+          </a:solidFill>
+          <a:ln>
+            <a:noFill/>
+          </a:ln>
+        </p:spPr>
+        <p:style>
+          <a:lnRef idx="1">
+            <a:schemeClr val="accent1"/>
+          </a:lnRef>
+          <a:fillRef idx="3">
+            <a:schemeClr val="accent1"/>
+          </a:fillRef>
+          <a:effectRef idx="2">
+            <a:schemeClr val="accent1"/>
+          </a:effectRef>
+          <a:fontRef idx="minor">
+            <a:schemeClr val="lt1"/>
+          </a:fontRef>
+        </p:style>
+        <p:txBody>
+          <a:bodyPr rtlCol="0" anchor="ctr"/>
+          <a:lstStyle/>
+          <a:p>
+            <a:pPr algn="ctr"/>
+          </a:p>
+        </p:txBody>
+      </p:sp>
+      <p:pic>
+        <p:nvPicPr>
+          <p:cNvPr id="14" name="Picture 13" descr="logo_crisp.png"/>
+          <p:cNvPicPr>
+            <a:picLocks noChangeAspect="1"/>
+          </p:cNvPicPr>
+          <p:nvPr/>
+        </p:nvPicPr>
+        <p:blipFill>
+          <a:blip r:embed="rId2"/>
+          <a:stretch>
+            <a:fillRect/>
+          </a:stretch>
+        </p:blipFill>
+        <p:spPr>
+          <a:xfrm>
+            <a:off x="9976103" y="128016"/>
+            <a:ext cx="2011680" cy="448056"/>
+          </a:xfrm>
+          <a:prstGeom prst="rect">
+            <a:avLst/>
+          </a:prstGeom>
+        </p:spPr>
+      </p:pic>
+      <p:sp>
+        <p:nvSpPr>
+          <p:cNvPr id="15" name="Rectangle 14"/>
+          <p:cNvSpPr/>
+          <p:nvPr/>
+        </p:nvSpPr>
+        <p:spPr>
+          <a:xfrm>
+            <a:off x="0" y="6387084"/>
+            <a:ext cx="12188952" cy="13716"/>
+          </a:xfrm>
+          <a:prstGeom prst="rect">
+            <a:avLst/>
+          </a:prstGeom>
+          <a:solidFill>
+            <a:srgbClr val="00D4FF"/>
+          </a:solidFill>
+          <a:ln>
+            <a:noFill/>
+          </a:ln>
+        </p:spPr>
+        <p:style>
+          <a:lnRef idx="1">
+            <a:schemeClr val="accent1"/>
+          </a:lnRef>
+          <a:fillRef idx="3">
+            <a:schemeClr val="accent1"/>
+          </a:fillRef>
+          <a:effectRef idx="2">
+            <a:schemeClr val="accent1"/>
+          </a:effectRef>
+          <a:fontRef idx="minor">
+            <a:schemeClr val="lt1"/>
+          </a:fontRef>
+        </p:style>
+        <p:txBody>
+          <a:bodyPr rtlCol="0" anchor="ctr"/>
+          <a:lstStyle/>
+          <a:p>
+            <a:pPr algn="ctr"/>
+          </a:p>
+        </p:txBody>
+      </p:sp>
+      <p:sp>
+        <p:nvSpPr>
+          <p:cNvPr id="16" name="Rectangle 15"/>
+          <p:cNvSpPr/>
+          <p:nvPr/>
+        </p:nvSpPr>
+        <p:spPr>
+          <a:xfrm>
+            <a:off x="0" y="6400800"/>
+            <a:ext cx="12188952" cy="457200"/>
+          </a:xfrm>
+          <a:prstGeom prst="rect">
+            <a:avLst/>
+          </a:prstGeom>
+          <a:solidFill>
+            <a:srgbClr val="051020"/>
+          </a:solidFill>
+          <a:ln>
+            <a:noFill/>
+          </a:ln>
+        </p:spPr>
+        <p:style>
+          <a:lnRef idx="1">
+            <a:schemeClr val="accent1"/>
+          </a:lnRef>
+          <a:fillRef idx="3">
+            <a:schemeClr val="accent1"/>
+          </a:fillRef>
+          <a:effectRef idx="2">
+            <a:schemeClr val="accent1"/>
+          </a:effectRef>
+          <a:fontRef idx="minor">
+            <a:schemeClr val="lt1"/>
+          </a:fontRef>
+        </p:style>
+        <p:txBody>
+          <a:bodyPr rtlCol="0" anchor="ctr"/>
+          <a:lstStyle/>
+          <a:p>
+            <a:pPr algn="ctr"/>
+          </a:p>
+        </p:txBody>
+      </p:sp>
+      <p:sp>
+        <p:nvSpPr>
+          <p:cNvPr id="17" name="Rectangle 16"/>
+          <p:cNvSpPr/>
+          <p:nvPr/>
+        </p:nvSpPr>
+        <p:spPr>
+          <a:xfrm>
+            <a:off x="0" y="6400800"/>
+            <a:ext cx="45720" cy="457200"/>
+          </a:xfrm>
+          <a:prstGeom prst="rect">
+            <a:avLst/>
+          </a:prstGeom>
+          <a:solidFill>
+            <a:srgbClr val="00D4FF"/>
+          </a:solidFill>
+          <a:ln>
+            <a:noFill/>
+          </a:ln>
+        </p:spPr>
+        <p:style>
+          <a:lnRef idx="1">
+            <a:schemeClr val="accent1"/>
+          </a:lnRef>
+          <a:fillRef idx="3">
+            <a:schemeClr val="accent1"/>
+          </a:fillRef>
+          <a:effectRef idx="2">
+            <a:schemeClr val="accent1"/>
+          </a:effectRef>
+          <a:fontRef idx="minor">
+            <a:schemeClr val="lt1"/>
+          </a:fontRef>
+        </p:style>
+        <p:txBody>
+          <a:bodyPr rtlCol="0" anchor="ctr"/>
+          <a:lstStyle/>
+          <a:p>
+            <a:pPr algn="ctr"/>
+          </a:p>
+        </p:txBody>
+      </p:sp>
+      <p:sp>
+        <p:nvSpPr>
+          <p:cNvPr id="18" name="TextBox 17"/>
+          <p:cNvSpPr txBox="1"/>
+          <p:nvPr/>
+        </p:nvSpPr>
+        <p:spPr>
+          <a:xfrm>
+            <a:off x="182880" y="6400800"/>
+            <a:ext cx="5029200" cy="457200"/>
+          </a:xfrm>
+          <a:prstGeom prst="rect">
+            <a:avLst/>
+          </a:prstGeom>
+          <a:noFill/>
+        </p:spPr>
+        <p:txBody>
+          <a:bodyPr wrap="none">
+            <a:spAutoFit/>
+          </a:bodyPr>
+          <a:lstStyle/>
+          <a:p>
+            <a:pPr algn="l"/>
+            <a:r>
+              <a:rPr sz="750" b="0">
+                <a:solidFill>
+                  <a:srgbClr val="B0C4D8"/>
+                </a:solidFill>
+                <a:latin typeface="Calibri"/>
+              </a:rPr>
+              <a:t>auxilab-eval-harness  |  AuxiLab Hackathon 2026</a:t>
+            </a:r>
+          </a:p>
+        </p:txBody>
+      </p:sp>
+      <p:sp>
+        <p:nvSpPr>
+          <p:cNvPr id="19" name="TextBox 18"/>
+          <p:cNvSpPr txBox="1"/>
+          <p:nvPr/>
+        </p:nvSpPr>
+        <p:spPr>
+          <a:xfrm>
+            <a:off x="11091672" y="6400800"/>
+            <a:ext cx="914400" cy="457200"/>
+          </a:xfrm>
+          <a:prstGeom prst="rect">
+            <a:avLst/>
+          </a:prstGeom>
+          <a:noFill/>
+        </p:spPr>
+        <p:txBody>
+          <a:bodyPr wrap="none">
+            <a:spAutoFit/>
+          </a:bodyPr>
+          <a:lstStyle/>
+          <a:p>
+            <a:pPr algn="r"/>
+            <a:r>
+              <a:rPr sz="800" b="1">
+                <a:solidFill>
+                  <a:srgbClr val="00D4FF"/>
+                </a:solidFill>
+                <a:latin typeface="Calibri"/>
+              </a:rPr>
+              <a:t>1  /  6</a:t>
+            </a:r>
+          </a:p>
+        </p:txBody>
+      </p:sp>
+      <p:sp>
+        <p:nvSpPr>
+          <p:cNvPr id="20" name="TextBox 19"/>
+          <p:cNvSpPr txBox="1"/>
+          <p:nvPr/>
+        </p:nvSpPr>
+        <p:spPr>
+          <a:xfrm>
+            <a:off x="9445752" y="6400800"/>
+            <a:ext cx="2468880" cy="457200"/>
+          </a:xfrm>
+          <a:prstGeom prst="rect">
+            <a:avLst/>
+          </a:prstGeom>
+          <a:noFill/>
+        </p:spPr>
+        <p:txBody>
+          <a:bodyPr wrap="none">
+            <a:spAutoFit/>
+          </a:bodyPr>
+          <a:lstStyle/>
+          <a:p>
+            <a:pPr algn="ctr"/>
+            <a:r>
+              <a:rPr sz="650" b="0">
+                <a:solidFill>
+                  <a:srgbClr val="5580A0"/>
+                </a:solidFill>
+                <a:latin typeface="Calibri"/>
+              </a:rPr>
+              <a:t>powered by auxiliobits</a:t>
+            </a:r>
           </a:p>
         </p:txBody>
       </p:sp>
@@ -4343,6 +4687,350 @@
           </a:p>
         </p:txBody>
       </p:sp>
+      <p:sp>
+        <p:nvSpPr>
+          <p:cNvPr id="11" name="Rectangle 10"/>
+          <p:cNvSpPr/>
+          <p:nvPr/>
+        </p:nvSpPr>
+        <p:spPr>
+          <a:xfrm>
+            <a:off x="9866376" y="51206"/>
+            <a:ext cx="2231136" cy="601675"/>
+          </a:xfrm>
+          <a:prstGeom prst="rect">
+            <a:avLst/>
+          </a:prstGeom>
+          <a:solidFill>
+            <a:srgbClr val="0D1B2A"/>
+          </a:solidFill>
+          <a:ln>
+            <a:noFill/>
+          </a:ln>
+        </p:spPr>
+        <p:style>
+          <a:lnRef idx="1">
+            <a:schemeClr val="accent1"/>
+          </a:lnRef>
+          <a:fillRef idx="3">
+            <a:schemeClr val="accent1"/>
+          </a:fillRef>
+          <a:effectRef idx="2">
+            <a:schemeClr val="accent1"/>
+          </a:effectRef>
+          <a:fontRef idx="minor">
+            <a:schemeClr val="lt1"/>
+          </a:fontRef>
+        </p:style>
+        <p:txBody>
+          <a:bodyPr rtlCol="0" anchor="ctr"/>
+          <a:lstStyle/>
+          <a:p>
+            <a:pPr algn="ctr"/>
+          </a:p>
+        </p:txBody>
+      </p:sp>
+      <p:sp>
+        <p:nvSpPr>
+          <p:cNvPr id="12" name="Rectangle 11"/>
+          <p:cNvSpPr/>
+          <p:nvPr/>
+        </p:nvSpPr>
+        <p:spPr>
+          <a:xfrm>
+            <a:off x="9866376" y="51206"/>
+            <a:ext cx="32004" cy="601675"/>
+          </a:xfrm>
+          <a:prstGeom prst="rect">
+            <a:avLst/>
+          </a:prstGeom>
+          <a:solidFill>
+            <a:srgbClr val="00D4FF"/>
+          </a:solidFill>
+          <a:ln>
+            <a:noFill/>
+          </a:ln>
+        </p:spPr>
+        <p:style>
+          <a:lnRef idx="1">
+            <a:schemeClr val="accent1"/>
+          </a:lnRef>
+          <a:fillRef idx="3">
+            <a:schemeClr val="accent1"/>
+          </a:fillRef>
+          <a:effectRef idx="2">
+            <a:schemeClr val="accent1"/>
+          </a:effectRef>
+          <a:fontRef idx="minor">
+            <a:schemeClr val="lt1"/>
+          </a:fontRef>
+        </p:style>
+        <p:txBody>
+          <a:bodyPr rtlCol="0" anchor="ctr"/>
+          <a:lstStyle/>
+          <a:p>
+            <a:pPr algn="ctr"/>
+          </a:p>
+        </p:txBody>
+      </p:sp>
+      <p:pic>
+        <p:nvPicPr>
+          <p:cNvPr id="13" name="Picture 12" descr="logo_crisp.png"/>
+          <p:cNvPicPr>
+            <a:picLocks noChangeAspect="1"/>
+          </p:cNvPicPr>
+          <p:nvPr/>
+        </p:nvPicPr>
+        <p:blipFill>
+          <a:blip r:embed="rId2"/>
+          <a:stretch>
+            <a:fillRect/>
+          </a:stretch>
+        </p:blipFill>
+        <p:spPr>
+          <a:xfrm>
+            <a:off x="9976103" y="128016"/>
+            <a:ext cx="2011680" cy="448056"/>
+          </a:xfrm>
+          <a:prstGeom prst="rect">
+            <a:avLst/>
+          </a:prstGeom>
+        </p:spPr>
+      </p:pic>
+      <p:sp>
+        <p:nvSpPr>
+          <p:cNvPr id="14" name="Rectangle 13"/>
+          <p:cNvSpPr/>
+          <p:nvPr/>
+        </p:nvSpPr>
+        <p:spPr>
+          <a:xfrm>
+            <a:off x="0" y="6387084"/>
+            <a:ext cx="12188952" cy="13716"/>
+          </a:xfrm>
+          <a:prstGeom prst="rect">
+            <a:avLst/>
+          </a:prstGeom>
+          <a:solidFill>
+            <a:srgbClr val="00D4FF"/>
+          </a:solidFill>
+          <a:ln>
+            <a:noFill/>
+          </a:ln>
+        </p:spPr>
+        <p:style>
+          <a:lnRef idx="1">
+            <a:schemeClr val="accent1"/>
+          </a:lnRef>
+          <a:fillRef idx="3">
+            <a:schemeClr val="accent1"/>
+          </a:fillRef>
+          <a:effectRef idx="2">
+            <a:schemeClr val="accent1"/>
+          </a:effectRef>
+          <a:fontRef idx="minor">
+            <a:schemeClr val="lt1"/>
+          </a:fontRef>
+        </p:style>
+        <p:txBody>
+          <a:bodyPr rtlCol="0" anchor="ctr"/>
+          <a:lstStyle/>
+          <a:p>
+            <a:pPr algn="ctr"/>
+          </a:p>
+        </p:txBody>
+      </p:sp>
+      <p:sp>
+        <p:nvSpPr>
+          <p:cNvPr id="15" name="Rectangle 14"/>
+          <p:cNvSpPr/>
+          <p:nvPr/>
+        </p:nvSpPr>
+        <p:spPr>
+          <a:xfrm>
+            <a:off x="0" y="6400800"/>
+            <a:ext cx="12188952" cy="457200"/>
+          </a:xfrm>
+          <a:prstGeom prst="rect">
+            <a:avLst/>
+          </a:prstGeom>
+          <a:solidFill>
+            <a:srgbClr val="051020"/>
+          </a:solidFill>
+          <a:ln>
+            <a:noFill/>
+          </a:ln>
+        </p:spPr>
+        <p:style>
+          <a:lnRef idx="1">
+            <a:schemeClr val="accent1"/>
+          </a:lnRef>
+          <a:fillRef idx="3">
+            <a:schemeClr val="accent1"/>
+          </a:fillRef>
+          <a:effectRef idx="2">
+            <a:schemeClr val="accent1"/>
+          </a:effectRef>
+          <a:fontRef idx="minor">
+            <a:schemeClr val="lt1"/>
+          </a:fontRef>
+        </p:style>
+        <p:txBody>
+          <a:bodyPr rtlCol="0" anchor="ctr"/>
+          <a:lstStyle/>
+          <a:p>
+            <a:pPr algn="ctr"/>
+          </a:p>
+        </p:txBody>
+      </p:sp>
+      <p:sp>
+        <p:nvSpPr>
+          <p:cNvPr id="16" name="Rectangle 15"/>
+          <p:cNvSpPr/>
+          <p:nvPr/>
+        </p:nvSpPr>
+        <p:spPr>
+          <a:xfrm>
+            <a:off x="0" y="6400800"/>
+            <a:ext cx="45720" cy="457200"/>
+          </a:xfrm>
+          <a:prstGeom prst="rect">
+            <a:avLst/>
+          </a:prstGeom>
+          <a:solidFill>
+            <a:srgbClr val="00D4FF"/>
+          </a:solidFill>
+          <a:ln>
+            <a:noFill/>
+          </a:ln>
+        </p:spPr>
+        <p:style>
+          <a:lnRef idx="1">
+            <a:schemeClr val="accent1"/>
+          </a:lnRef>
+          <a:fillRef idx="3">
+            <a:schemeClr val="accent1"/>
+          </a:fillRef>
+          <a:effectRef idx="2">
+            <a:schemeClr val="accent1"/>
+          </a:effectRef>
+          <a:fontRef idx="minor">
+            <a:schemeClr val="lt1"/>
+          </a:fontRef>
+        </p:style>
+        <p:txBody>
+          <a:bodyPr rtlCol="0" anchor="ctr"/>
+          <a:lstStyle/>
+          <a:p>
+            <a:pPr algn="ctr"/>
+          </a:p>
+        </p:txBody>
+      </p:sp>
+      <p:sp>
+        <p:nvSpPr>
+          <p:cNvPr id="17" name="TextBox 16"/>
+          <p:cNvSpPr txBox="1"/>
+          <p:nvPr/>
+        </p:nvSpPr>
+        <p:spPr>
+          <a:xfrm>
+            <a:off x="182880" y="6400800"/>
+            <a:ext cx="5029200" cy="457200"/>
+          </a:xfrm>
+          <a:prstGeom prst="rect">
+            <a:avLst/>
+          </a:prstGeom>
+          <a:noFill/>
+        </p:spPr>
+        <p:txBody>
+          <a:bodyPr wrap="none">
+            <a:spAutoFit/>
+          </a:bodyPr>
+          <a:lstStyle/>
+          <a:p>
+            <a:pPr algn="l"/>
+            <a:r>
+              <a:rPr sz="750" b="0">
+                <a:solidFill>
+                  <a:srgbClr val="B0C4D8"/>
+                </a:solidFill>
+                <a:latin typeface="Calibri"/>
+              </a:rPr>
+              <a:t>auxilab-eval-harness  |  AuxiLab Hackathon 2026</a:t>
+            </a:r>
+          </a:p>
+        </p:txBody>
+      </p:sp>
+      <p:sp>
+        <p:nvSpPr>
+          <p:cNvPr id="18" name="TextBox 17"/>
+          <p:cNvSpPr txBox="1"/>
+          <p:nvPr/>
+        </p:nvSpPr>
+        <p:spPr>
+          <a:xfrm>
+            <a:off x="11091672" y="6400800"/>
+            <a:ext cx="914400" cy="457200"/>
+          </a:xfrm>
+          <a:prstGeom prst="rect">
+            <a:avLst/>
+          </a:prstGeom>
+          <a:noFill/>
+        </p:spPr>
+        <p:txBody>
+          <a:bodyPr wrap="none">
+            <a:spAutoFit/>
+          </a:bodyPr>
+          <a:lstStyle/>
+          <a:p>
+            <a:pPr algn="r"/>
+            <a:r>
+              <a:rPr sz="800" b="1">
+                <a:solidFill>
+                  <a:srgbClr val="00D4FF"/>
+                </a:solidFill>
+                <a:latin typeface="Calibri"/>
+              </a:rPr>
+              <a:t>2  /  6</a:t>
+            </a:r>
+          </a:p>
+        </p:txBody>
+      </p:sp>
+      <p:sp>
+        <p:nvSpPr>
+          <p:cNvPr id="19" name="TextBox 18"/>
+          <p:cNvSpPr txBox="1"/>
+          <p:nvPr/>
+        </p:nvSpPr>
+        <p:spPr>
+          <a:xfrm>
+            <a:off x="9445752" y="6400800"/>
+            <a:ext cx="2468880" cy="457200"/>
+          </a:xfrm>
+          <a:prstGeom prst="rect">
+            <a:avLst/>
+          </a:prstGeom>
+          <a:noFill/>
+        </p:spPr>
+        <p:txBody>
+          <a:bodyPr wrap="none">
+            <a:spAutoFit/>
+          </a:bodyPr>
+          <a:lstStyle/>
+          <a:p>
+            <a:pPr algn="ctr"/>
+            <a:r>
+              <a:rPr sz="650" b="0">
+                <a:solidFill>
+                  <a:srgbClr val="5580A0"/>
+                </a:solidFill>
+                <a:latin typeface="Calibri"/>
+              </a:rPr>
+              <a:t>powered by auxiliobits</a:t>
+            </a:r>
+          </a:p>
+        </p:txBody>
+      </p:sp>
     </p:spTree>
   </p:cSld>
   <p:clrMapOvr>
@@ -5043,6 +5731,350 @@
   --tests ap_tests.yaml \
   --agent demo.agent:handle \
   --html report.html</a:t>
+            </a:r>
+          </a:p>
+        </p:txBody>
+      </p:sp>
+      <p:sp>
+        <p:nvSpPr>
+          <p:cNvPr id="15" name="Rectangle 14"/>
+          <p:cNvSpPr/>
+          <p:nvPr/>
+        </p:nvSpPr>
+        <p:spPr>
+          <a:xfrm>
+            <a:off x="9866376" y="51206"/>
+            <a:ext cx="2231136" cy="601675"/>
+          </a:xfrm>
+          <a:prstGeom prst="rect">
+            <a:avLst/>
+          </a:prstGeom>
+          <a:solidFill>
+            <a:srgbClr val="0D1B2A"/>
+          </a:solidFill>
+          <a:ln>
+            <a:noFill/>
+          </a:ln>
+        </p:spPr>
+        <p:style>
+          <a:lnRef idx="1">
+            <a:schemeClr val="accent1"/>
+          </a:lnRef>
+          <a:fillRef idx="3">
+            <a:schemeClr val="accent1"/>
+          </a:fillRef>
+          <a:effectRef idx="2">
+            <a:schemeClr val="accent1"/>
+          </a:effectRef>
+          <a:fontRef idx="minor">
+            <a:schemeClr val="lt1"/>
+          </a:fontRef>
+        </p:style>
+        <p:txBody>
+          <a:bodyPr rtlCol="0" anchor="ctr"/>
+          <a:lstStyle/>
+          <a:p>
+            <a:pPr algn="ctr"/>
+          </a:p>
+        </p:txBody>
+      </p:sp>
+      <p:sp>
+        <p:nvSpPr>
+          <p:cNvPr id="16" name="Rectangle 15"/>
+          <p:cNvSpPr/>
+          <p:nvPr/>
+        </p:nvSpPr>
+        <p:spPr>
+          <a:xfrm>
+            <a:off x="9866376" y="51206"/>
+            <a:ext cx="32004" cy="601675"/>
+          </a:xfrm>
+          <a:prstGeom prst="rect">
+            <a:avLst/>
+          </a:prstGeom>
+          <a:solidFill>
+            <a:srgbClr val="00D4FF"/>
+          </a:solidFill>
+          <a:ln>
+            <a:noFill/>
+          </a:ln>
+        </p:spPr>
+        <p:style>
+          <a:lnRef idx="1">
+            <a:schemeClr val="accent1"/>
+          </a:lnRef>
+          <a:fillRef idx="3">
+            <a:schemeClr val="accent1"/>
+          </a:fillRef>
+          <a:effectRef idx="2">
+            <a:schemeClr val="accent1"/>
+          </a:effectRef>
+          <a:fontRef idx="minor">
+            <a:schemeClr val="lt1"/>
+          </a:fontRef>
+        </p:style>
+        <p:txBody>
+          <a:bodyPr rtlCol="0" anchor="ctr"/>
+          <a:lstStyle/>
+          <a:p>
+            <a:pPr algn="ctr"/>
+          </a:p>
+        </p:txBody>
+      </p:sp>
+      <p:pic>
+        <p:nvPicPr>
+          <p:cNvPr id="17" name="Picture 16" descr="logo_crisp.png"/>
+          <p:cNvPicPr>
+            <a:picLocks noChangeAspect="1"/>
+          </p:cNvPicPr>
+          <p:nvPr/>
+        </p:nvPicPr>
+        <p:blipFill>
+          <a:blip r:embed="rId2"/>
+          <a:stretch>
+            <a:fillRect/>
+          </a:stretch>
+        </p:blipFill>
+        <p:spPr>
+          <a:xfrm>
+            <a:off x="9976103" y="128016"/>
+            <a:ext cx="2011680" cy="448056"/>
+          </a:xfrm>
+          <a:prstGeom prst="rect">
+            <a:avLst/>
+          </a:prstGeom>
+        </p:spPr>
+      </p:pic>
+      <p:sp>
+        <p:nvSpPr>
+          <p:cNvPr id="18" name="Rectangle 17"/>
+          <p:cNvSpPr/>
+          <p:nvPr/>
+        </p:nvSpPr>
+        <p:spPr>
+          <a:xfrm>
+            <a:off x="0" y="6387084"/>
+            <a:ext cx="12188952" cy="13716"/>
+          </a:xfrm>
+          <a:prstGeom prst="rect">
+            <a:avLst/>
+          </a:prstGeom>
+          <a:solidFill>
+            <a:srgbClr val="00D4FF"/>
+          </a:solidFill>
+          <a:ln>
+            <a:noFill/>
+          </a:ln>
+        </p:spPr>
+        <p:style>
+          <a:lnRef idx="1">
+            <a:schemeClr val="accent1"/>
+          </a:lnRef>
+          <a:fillRef idx="3">
+            <a:schemeClr val="accent1"/>
+          </a:fillRef>
+          <a:effectRef idx="2">
+            <a:schemeClr val="accent1"/>
+          </a:effectRef>
+          <a:fontRef idx="minor">
+            <a:schemeClr val="lt1"/>
+          </a:fontRef>
+        </p:style>
+        <p:txBody>
+          <a:bodyPr rtlCol="0" anchor="ctr"/>
+          <a:lstStyle/>
+          <a:p>
+            <a:pPr algn="ctr"/>
+          </a:p>
+        </p:txBody>
+      </p:sp>
+      <p:sp>
+        <p:nvSpPr>
+          <p:cNvPr id="19" name="Rectangle 18"/>
+          <p:cNvSpPr/>
+          <p:nvPr/>
+        </p:nvSpPr>
+        <p:spPr>
+          <a:xfrm>
+            <a:off x="0" y="6400800"/>
+            <a:ext cx="12188952" cy="457200"/>
+          </a:xfrm>
+          <a:prstGeom prst="rect">
+            <a:avLst/>
+          </a:prstGeom>
+          <a:solidFill>
+            <a:srgbClr val="051020"/>
+          </a:solidFill>
+          <a:ln>
+            <a:noFill/>
+          </a:ln>
+        </p:spPr>
+        <p:style>
+          <a:lnRef idx="1">
+            <a:schemeClr val="accent1"/>
+          </a:lnRef>
+          <a:fillRef idx="3">
+            <a:schemeClr val="accent1"/>
+          </a:fillRef>
+          <a:effectRef idx="2">
+            <a:schemeClr val="accent1"/>
+          </a:effectRef>
+          <a:fontRef idx="minor">
+            <a:schemeClr val="lt1"/>
+          </a:fontRef>
+        </p:style>
+        <p:txBody>
+          <a:bodyPr rtlCol="0" anchor="ctr"/>
+          <a:lstStyle/>
+          <a:p>
+            <a:pPr algn="ctr"/>
+          </a:p>
+        </p:txBody>
+      </p:sp>
+      <p:sp>
+        <p:nvSpPr>
+          <p:cNvPr id="20" name="Rectangle 19"/>
+          <p:cNvSpPr/>
+          <p:nvPr/>
+        </p:nvSpPr>
+        <p:spPr>
+          <a:xfrm>
+            <a:off x="0" y="6400800"/>
+            <a:ext cx="45720" cy="457200"/>
+          </a:xfrm>
+          <a:prstGeom prst="rect">
+            <a:avLst/>
+          </a:prstGeom>
+          <a:solidFill>
+            <a:srgbClr val="00D4FF"/>
+          </a:solidFill>
+          <a:ln>
+            <a:noFill/>
+          </a:ln>
+        </p:spPr>
+        <p:style>
+          <a:lnRef idx="1">
+            <a:schemeClr val="accent1"/>
+          </a:lnRef>
+          <a:fillRef idx="3">
+            <a:schemeClr val="accent1"/>
+          </a:fillRef>
+          <a:effectRef idx="2">
+            <a:schemeClr val="accent1"/>
+          </a:effectRef>
+          <a:fontRef idx="minor">
+            <a:schemeClr val="lt1"/>
+          </a:fontRef>
+        </p:style>
+        <p:txBody>
+          <a:bodyPr rtlCol="0" anchor="ctr"/>
+          <a:lstStyle/>
+          <a:p>
+            <a:pPr algn="ctr"/>
+          </a:p>
+        </p:txBody>
+      </p:sp>
+      <p:sp>
+        <p:nvSpPr>
+          <p:cNvPr id="21" name="TextBox 20"/>
+          <p:cNvSpPr txBox="1"/>
+          <p:nvPr/>
+        </p:nvSpPr>
+        <p:spPr>
+          <a:xfrm>
+            <a:off x="182880" y="6400800"/>
+            <a:ext cx="5029200" cy="457200"/>
+          </a:xfrm>
+          <a:prstGeom prst="rect">
+            <a:avLst/>
+          </a:prstGeom>
+          <a:noFill/>
+        </p:spPr>
+        <p:txBody>
+          <a:bodyPr wrap="none">
+            <a:spAutoFit/>
+          </a:bodyPr>
+          <a:lstStyle/>
+          <a:p>
+            <a:pPr algn="l"/>
+            <a:r>
+              <a:rPr sz="750" b="0">
+                <a:solidFill>
+                  <a:srgbClr val="B0C4D8"/>
+                </a:solidFill>
+                <a:latin typeface="Calibri"/>
+              </a:rPr>
+              <a:t>auxilab-eval-harness  |  AuxiLab Hackathon 2026</a:t>
+            </a:r>
+          </a:p>
+        </p:txBody>
+      </p:sp>
+      <p:sp>
+        <p:nvSpPr>
+          <p:cNvPr id="22" name="TextBox 21"/>
+          <p:cNvSpPr txBox="1"/>
+          <p:nvPr/>
+        </p:nvSpPr>
+        <p:spPr>
+          <a:xfrm>
+            <a:off x="11091672" y="6400800"/>
+            <a:ext cx="914400" cy="457200"/>
+          </a:xfrm>
+          <a:prstGeom prst="rect">
+            <a:avLst/>
+          </a:prstGeom>
+          <a:noFill/>
+        </p:spPr>
+        <p:txBody>
+          <a:bodyPr wrap="none">
+            <a:spAutoFit/>
+          </a:bodyPr>
+          <a:lstStyle/>
+          <a:p>
+            <a:pPr algn="r"/>
+            <a:r>
+              <a:rPr sz="800" b="1">
+                <a:solidFill>
+                  <a:srgbClr val="00D4FF"/>
+                </a:solidFill>
+                <a:latin typeface="Calibri"/>
+              </a:rPr>
+              <a:t>3  /  6</a:t>
+            </a:r>
+          </a:p>
+        </p:txBody>
+      </p:sp>
+      <p:sp>
+        <p:nvSpPr>
+          <p:cNvPr id="23" name="TextBox 22"/>
+          <p:cNvSpPr txBox="1"/>
+          <p:nvPr/>
+        </p:nvSpPr>
+        <p:spPr>
+          <a:xfrm>
+            <a:off x="9445752" y="6400800"/>
+            <a:ext cx="2468880" cy="457200"/>
+          </a:xfrm>
+          <a:prstGeom prst="rect">
+            <a:avLst/>
+          </a:prstGeom>
+          <a:noFill/>
+        </p:spPr>
+        <p:txBody>
+          <a:bodyPr wrap="none">
+            <a:spAutoFit/>
+          </a:bodyPr>
+          <a:lstStyle/>
+          <a:p>
+            <a:pPr algn="ctr"/>
+            <a:r>
+              <a:rPr sz="650" b="0">
+                <a:solidFill>
+                  <a:srgbClr val="5580A0"/>
+                </a:solidFill>
+                <a:latin typeface="Calibri"/>
+              </a:rPr>
+              <a:t>powered by auxiliobits</a:t>
             </a:r>
           </a:p>
         </p:txBody>
@@ -6309,6 +7341,350 @@
           </a:p>
         </p:txBody>
       </p:sp>
+      <p:sp>
+        <p:nvSpPr>
+          <p:cNvPr id="13" name="Rectangle 12"/>
+          <p:cNvSpPr/>
+          <p:nvPr/>
+        </p:nvSpPr>
+        <p:spPr>
+          <a:xfrm>
+            <a:off x="9866376" y="51206"/>
+            <a:ext cx="2231136" cy="601675"/>
+          </a:xfrm>
+          <a:prstGeom prst="rect">
+            <a:avLst/>
+          </a:prstGeom>
+          <a:solidFill>
+            <a:srgbClr val="0D1B2A"/>
+          </a:solidFill>
+          <a:ln>
+            <a:noFill/>
+          </a:ln>
+        </p:spPr>
+        <p:style>
+          <a:lnRef idx="1">
+            <a:schemeClr val="accent1"/>
+          </a:lnRef>
+          <a:fillRef idx="3">
+            <a:schemeClr val="accent1"/>
+          </a:fillRef>
+          <a:effectRef idx="2">
+            <a:schemeClr val="accent1"/>
+          </a:effectRef>
+          <a:fontRef idx="minor">
+            <a:schemeClr val="lt1"/>
+          </a:fontRef>
+        </p:style>
+        <p:txBody>
+          <a:bodyPr rtlCol="0" anchor="ctr"/>
+          <a:lstStyle/>
+          <a:p>
+            <a:pPr algn="ctr"/>
+          </a:p>
+        </p:txBody>
+      </p:sp>
+      <p:sp>
+        <p:nvSpPr>
+          <p:cNvPr id="14" name="Rectangle 13"/>
+          <p:cNvSpPr/>
+          <p:nvPr/>
+        </p:nvSpPr>
+        <p:spPr>
+          <a:xfrm>
+            <a:off x="9866376" y="51206"/>
+            <a:ext cx="32004" cy="601675"/>
+          </a:xfrm>
+          <a:prstGeom prst="rect">
+            <a:avLst/>
+          </a:prstGeom>
+          <a:solidFill>
+            <a:srgbClr val="00D4FF"/>
+          </a:solidFill>
+          <a:ln>
+            <a:noFill/>
+          </a:ln>
+        </p:spPr>
+        <p:style>
+          <a:lnRef idx="1">
+            <a:schemeClr val="accent1"/>
+          </a:lnRef>
+          <a:fillRef idx="3">
+            <a:schemeClr val="accent1"/>
+          </a:fillRef>
+          <a:effectRef idx="2">
+            <a:schemeClr val="accent1"/>
+          </a:effectRef>
+          <a:fontRef idx="minor">
+            <a:schemeClr val="lt1"/>
+          </a:fontRef>
+        </p:style>
+        <p:txBody>
+          <a:bodyPr rtlCol="0" anchor="ctr"/>
+          <a:lstStyle/>
+          <a:p>
+            <a:pPr algn="ctr"/>
+          </a:p>
+        </p:txBody>
+      </p:sp>
+      <p:pic>
+        <p:nvPicPr>
+          <p:cNvPr id="15" name="Picture 14" descr="logo_crisp.png"/>
+          <p:cNvPicPr>
+            <a:picLocks noChangeAspect="1"/>
+          </p:cNvPicPr>
+          <p:nvPr/>
+        </p:nvPicPr>
+        <p:blipFill>
+          <a:blip r:embed="rId2"/>
+          <a:stretch>
+            <a:fillRect/>
+          </a:stretch>
+        </p:blipFill>
+        <p:spPr>
+          <a:xfrm>
+            <a:off x="9976103" y="128016"/>
+            <a:ext cx="2011680" cy="448056"/>
+          </a:xfrm>
+          <a:prstGeom prst="rect">
+            <a:avLst/>
+          </a:prstGeom>
+        </p:spPr>
+      </p:pic>
+      <p:sp>
+        <p:nvSpPr>
+          <p:cNvPr id="16" name="Rectangle 15"/>
+          <p:cNvSpPr/>
+          <p:nvPr/>
+        </p:nvSpPr>
+        <p:spPr>
+          <a:xfrm>
+            <a:off x="0" y="6387084"/>
+            <a:ext cx="12188952" cy="13716"/>
+          </a:xfrm>
+          <a:prstGeom prst="rect">
+            <a:avLst/>
+          </a:prstGeom>
+          <a:solidFill>
+            <a:srgbClr val="00D4FF"/>
+          </a:solidFill>
+          <a:ln>
+            <a:noFill/>
+          </a:ln>
+        </p:spPr>
+        <p:style>
+          <a:lnRef idx="1">
+            <a:schemeClr val="accent1"/>
+          </a:lnRef>
+          <a:fillRef idx="3">
+            <a:schemeClr val="accent1"/>
+          </a:fillRef>
+          <a:effectRef idx="2">
+            <a:schemeClr val="accent1"/>
+          </a:effectRef>
+          <a:fontRef idx="minor">
+            <a:schemeClr val="lt1"/>
+          </a:fontRef>
+        </p:style>
+        <p:txBody>
+          <a:bodyPr rtlCol="0" anchor="ctr"/>
+          <a:lstStyle/>
+          <a:p>
+            <a:pPr algn="ctr"/>
+          </a:p>
+        </p:txBody>
+      </p:sp>
+      <p:sp>
+        <p:nvSpPr>
+          <p:cNvPr id="17" name="Rectangle 16"/>
+          <p:cNvSpPr/>
+          <p:nvPr/>
+        </p:nvSpPr>
+        <p:spPr>
+          <a:xfrm>
+            <a:off x="0" y="6400800"/>
+            <a:ext cx="12188952" cy="457200"/>
+          </a:xfrm>
+          <a:prstGeom prst="rect">
+            <a:avLst/>
+          </a:prstGeom>
+          <a:solidFill>
+            <a:srgbClr val="051020"/>
+          </a:solidFill>
+          <a:ln>
+            <a:noFill/>
+          </a:ln>
+        </p:spPr>
+        <p:style>
+          <a:lnRef idx="1">
+            <a:schemeClr val="accent1"/>
+          </a:lnRef>
+          <a:fillRef idx="3">
+            <a:schemeClr val="accent1"/>
+          </a:fillRef>
+          <a:effectRef idx="2">
+            <a:schemeClr val="accent1"/>
+          </a:effectRef>
+          <a:fontRef idx="minor">
+            <a:schemeClr val="lt1"/>
+          </a:fontRef>
+        </p:style>
+        <p:txBody>
+          <a:bodyPr rtlCol="0" anchor="ctr"/>
+          <a:lstStyle/>
+          <a:p>
+            <a:pPr algn="ctr"/>
+          </a:p>
+        </p:txBody>
+      </p:sp>
+      <p:sp>
+        <p:nvSpPr>
+          <p:cNvPr id="18" name="Rectangle 17"/>
+          <p:cNvSpPr/>
+          <p:nvPr/>
+        </p:nvSpPr>
+        <p:spPr>
+          <a:xfrm>
+            <a:off x="0" y="6400800"/>
+            <a:ext cx="45720" cy="457200"/>
+          </a:xfrm>
+          <a:prstGeom prst="rect">
+            <a:avLst/>
+          </a:prstGeom>
+          <a:solidFill>
+            <a:srgbClr val="00D4FF"/>
+          </a:solidFill>
+          <a:ln>
+            <a:noFill/>
+          </a:ln>
+        </p:spPr>
+        <p:style>
+          <a:lnRef idx="1">
+            <a:schemeClr val="accent1"/>
+          </a:lnRef>
+          <a:fillRef idx="3">
+            <a:schemeClr val="accent1"/>
+          </a:fillRef>
+          <a:effectRef idx="2">
+            <a:schemeClr val="accent1"/>
+          </a:effectRef>
+          <a:fontRef idx="minor">
+            <a:schemeClr val="lt1"/>
+          </a:fontRef>
+        </p:style>
+        <p:txBody>
+          <a:bodyPr rtlCol="0" anchor="ctr"/>
+          <a:lstStyle/>
+          <a:p>
+            <a:pPr algn="ctr"/>
+          </a:p>
+        </p:txBody>
+      </p:sp>
+      <p:sp>
+        <p:nvSpPr>
+          <p:cNvPr id="19" name="TextBox 18"/>
+          <p:cNvSpPr txBox="1"/>
+          <p:nvPr/>
+        </p:nvSpPr>
+        <p:spPr>
+          <a:xfrm>
+            <a:off x="182880" y="6400800"/>
+            <a:ext cx="5029200" cy="457200"/>
+          </a:xfrm>
+          <a:prstGeom prst="rect">
+            <a:avLst/>
+          </a:prstGeom>
+          <a:noFill/>
+        </p:spPr>
+        <p:txBody>
+          <a:bodyPr wrap="none">
+            <a:spAutoFit/>
+          </a:bodyPr>
+          <a:lstStyle/>
+          <a:p>
+            <a:pPr algn="l"/>
+            <a:r>
+              <a:rPr sz="750" b="0">
+                <a:solidFill>
+                  <a:srgbClr val="B0C4D8"/>
+                </a:solidFill>
+                <a:latin typeface="Calibri"/>
+              </a:rPr>
+              <a:t>auxilab-eval-harness  |  AuxiLab Hackathon 2026</a:t>
+            </a:r>
+          </a:p>
+        </p:txBody>
+      </p:sp>
+      <p:sp>
+        <p:nvSpPr>
+          <p:cNvPr id="20" name="TextBox 19"/>
+          <p:cNvSpPr txBox="1"/>
+          <p:nvPr/>
+        </p:nvSpPr>
+        <p:spPr>
+          <a:xfrm>
+            <a:off x="11091672" y="6400800"/>
+            <a:ext cx="914400" cy="457200"/>
+          </a:xfrm>
+          <a:prstGeom prst="rect">
+            <a:avLst/>
+          </a:prstGeom>
+          <a:noFill/>
+        </p:spPr>
+        <p:txBody>
+          <a:bodyPr wrap="none">
+            <a:spAutoFit/>
+          </a:bodyPr>
+          <a:lstStyle/>
+          <a:p>
+            <a:pPr algn="r"/>
+            <a:r>
+              <a:rPr sz="800" b="1">
+                <a:solidFill>
+                  <a:srgbClr val="00D4FF"/>
+                </a:solidFill>
+                <a:latin typeface="Calibri"/>
+              </a:rPr>
+              <a:t>4  /  6</a:t>
+            </a:r>
+          </a:p>
+        </p:txBody>
+      </p:sp>
+      <p:sp>
+        <p:nvSpPr>
+          <p:cNvPr id="21" name="TextBox 20"/>
+          <p:cNvSpPr txBox="1"/>
+          <p:nvPr/>
+        </p:nvSpPr>
+        <p:spPr>
+          <a:xfrm>
+            <a:off x="9445752" y="6400800"/>
+            <a:ext cx="2468880" cy="457200"/>
+          </a:xfrm>
+          <a:prstGeom prst="rect">
+            <a:avLst/>
+          </a:prstGeom>
+          <a:noFill/>
+        </p:spPr>
+        <p:txBody>
+          <a:bodyPr wrap="none">
+            <a:spAutoFit/>
+          </a:bodyPr>
+          <a:lstStyle/>
+          <a:p>
+            <a:pPr algn="ctr"/>
+            <a:r>
+              <a:rPr sz="650" b="0">
+                <a:solidFill>
+                  <a:srgbClr val="5580A0"/>
+                </a:solidFill>
+                <a:latin typeface="Calibri"/>
+              </a:rPr>
+              <a:t>powered by auxiliobits</a:t>
+            </a:r>
+          </a:p>
+        </p:txBody>
+      </p:sp>
     </p:spTree>
   </p:cSld>
   <p:clrMapOvr>
@@ -7224,6 +8600,350 @@
                 </a:solidFill>
               </a:rPr>
               <a:t>github.com/AuxiLabs-Auxiliobits/auxilab-eval-harness</a:t>
+            </a:r>
+          </a:p>
+        </p:txBody>
+      </p:sp>
+      <p:sp>
+        <p:nvSpPr>
+          <p:cNvPr id="22" name="Rectangle 21"/>
+          <p:cNvSpPr/>
+          <p:nvPr/>
+        </p:nvSpPr>
+        <p:spPr>
+          <a:xfrm>
+            <a:off x="9866376" y="51206"/>
+            <a:ext cx="2231136" cy="601675"/>
+          </a:xfrm>
+          <a:prstGeom prst="rect">
+            <a:avLst/>
+          </a:prstGeom>
+          <a:solidFill>
+            <a:srgbClr val="0D1B2A"/>
+          </a:solidFill>
+          <a:ln>
+            <a:noFill/>
+          </a:ln>
+        </p:spPr>
+        <p:style>
+          <a:lnRef idx="1">
+            <a:schemeClr val="accent1"/>
+          </a:lnRef>
+          <a:fillRef idx="3">
+            <a:schemeClr val="accent1"/>
+          </a:fillRef>
+          <a:effectRef idx="2">
+            <a:schemeClr val="accent1"/>
+          </a:effectRef>
+          <a:fontRef idx="minor">
+            <a:schemeClr val="lt1"/>
+          </a:fontRef>
+        </p:style>
+        <p:txBody>
+          <a:bodyPr rtlCol="0" anchor="ctr"/>
+          <a:lstStyle/>
+          <a:p>
+            <a:pPr algn="ctr"/>
+          </a:p>
+        </p:txBody>
+      </p:sp>
+      <p:sp>
+        <p:nvSpPr>
+          <p:cNvPr id="23" name="Rectangle 22"/>
+          <p:cNvSpPr/>
+          <p:nvPr/>
+        </p:nvSpPr>
+        <p:spPr>
+          <a:xfrm>
+            <a:off x="9866376" y="51206"/>
+            <a:ext cx="32004" cy="601675"/>
+          </a:xfrm>
+          <a:prstGeom prst="rect">
+            <a:avLst/>
+          </a:prstGeom>
+          <a:solidFill>
+            <a:srgbClr val="00D4FF"/>
+          </a:solidFill>
+          <a:ln>
+            <a:noFill/>
+          </a:ln>
+        </p:spPr>
+        <p:style>
+          <a:lnRef idx="1">
+            <a:schemeClr val="accent1"/>
+          </a:lnRef>
+          <a:fillRef idx="3">
+            <a:schemeClr val="accent1"/>
+          </a:fillRef>
+          <a:effectRef idx="2">
+            <a:schemeClr val="accent1"/>
+          </a:effectRef>
+          <a:fontRef idx="minor">
+            <a:schemeClr val="lt1"/>
+          </a:fontRef>
+        </p:style>
+        <p:txBody>
+          <a:bodyPr rtlCol="0" anchor="ctr"/>
+          <a:lstStyle/>
+          <a:p>
+            <a:pPr algn="ctr"/>
+          </a:p>
+        </p:txBody>
+      </p:sp>
+      <p:pic>
+        <p:nvPicPr>
+          <p:cNvPr id="24" name="Picture 23" descr="logo_crisp.png"/>
+          <p:cNvPicPr>
+            <a:picLocks noChangeAspect="1"/>
+          </p:cNvPicPr>
+          <p:nvPr/>
+        </p:nvPicPr>
+        <p:blipFill>
+          <a:blip r:embed="rId2"/>
+          <a:stretch>
+            <a:fillRect/>
+          </a:stretch>
+        </p:blipFill>
+        <p:spPr>
+          <a:xfrm>
+            <a:off x="9976103" y="128016"/>
+            <a:ext cx="2011680" cy="448056"/>
+          </a:xfrm>
+          <a:prstGeom prst="rect">
+            <a:avLst/>
+          </a:prstGeom>
+        </p:spPr>
+      </p:pic>
+      <p:sp>
+        <p:nvSpPr>
+          <p:cNvPr id="25" name="Rectangle 24"/>
+          <p:cNvSpPr/>
+          <p:nvPr/>
+        </p:nvSpPr>
+        <p:spPr>
+          <a:xfrm>
+            <a:off x="0" y="6387084"/>
+            <a:ext cx="12188952" cy="13716"/>
+          </a:xfrm>
+          <a:prstGeom prst="rect">
+            <a:avLst/>
+          </a:prstGeom>
+          <a:solidFill>
+            <a:srgbClr val="00D4FF"/>
+          </a:solidFill>
+          <a:ln>
+            <a:noFill/>
+          </a:ln>
+        </p:spPr>
+        <p:style>
+          <a:lnRef idx="1">
+            <a:schemeClr val="accent1"/>
+          </a:lnRef>
+          <a:fillRef idx="3">
+            <a:schemeClr val="accent1"/>
+          </a:fillRef>
+          <a:effectRef idx="2">
+            <a:schemeClr val="accent1"/>
+          </a:effectRef>
+          <a:fontRef idx="minor">
+            <a:schemeClr val="lt1"/>
+          </a:fontRef>
+        </p:style>
+        <p:txBody>
+          <a:bodyPr rtlCol="0" anchor="ctr"/>
+          <a:lstStyle/>
+          <a:p>
+            <a:pPr algn="ctr"/>
+          </a:p>
+        </p:txBody>
+      </p:sp>
+      <p:sp>
+        <p:nvSpPr>
+          <p:cNvPr id="26" name="Rectangle 25"/>
+          <p:cNvSpPr/>
+          <p:nvPr/>
+        </p:nvSpPr>
+        <p:spPr>
+          <a:xfrm>
+            <a:off x="0" y="6400800"/>
+            <a:ext cx="12188952" cy="457200"/>
+          </a:xfrm>
+          <a:prstGeom prst="rect">
+            <a:avLst/>
+          </a:prstGeom>
+          <a:solidFill>
+            <a:srgbClr val="051020"/>
+          </a:solidFill>
+          <a:ln>
+            <a:noFill/>
+          </a:ln>
+        </p:spPr>
+        <p:style>
+          <a:lnRef idx="1">
+            <a:schemeClr val="accent1"/>
+          </a:lnRef>
+          <a:fillRef idx="3">
+            <a:schemeClr val="accent1"/>
+          </a:fillRef>
+          <a:effectRef idx="2">
+            <a:schemeClr val="accent1"/>
+          </a:effectRef>
+          <a:fontRef idx="minor">
+            <a:schemeClr val="lt1"/>
+          </a:fontRef>
+        </p:style>
+        <p:txBody>
+          <a:bodyPr rtlCol="0" anchor="ctr"/>
+          <a:lstStyle/>
+          <a:p>
+            <a:pPr algn="ctr"/>
+          </a:p>
+        </p:txBody>
+      </p:sp>
+      <p:sp>
+        <p:nvSpPr>
+          <p:cNvPr id="27" name="Rectangle 26"/>
+          <p:cNvSpPr/>
+          <p:nvPr/>
+        </p:nvSpPr>
+        <p:spPr>
+          <a:xfrm>
+            <a:off x="0" y="6400800"/>
+            <a:ext cx="45720" cy="457200"/>
+          </a:xfrm>
+          <a:prstGeom prst="rect">
+            <a:avLst/>
+          </a:prstGeom>
+          <a:solidFill>
+            <a:srgbClr val="00D4FF"/>
+          </a:solidFill>
+          <a:ln>
+            <a:noFill/>
+          </a:ln>
+        </p:spPr>
+        <p:style>
+          <a:lnRef idx="1">
+            <a:schemeClr val="accent1"/>
+          </a:lnRef>
+          <a:fillRef idx="3">
+            <a:schemeClr val="accent1"/>
+          </a:fillRef>
+          <a:effectRef idx="2">
+            <a:schemeClr val="accent1"/>
+          </a:effectRef>
+          <a:fontRef idx="minor">
+            <a:schemeClr val="lt1"/>
+          </a:fontRef>
+        </p:style>
+        <p:txBody>
+          <a:bodyPr rtlCol="0" anchor="ctr"/>
+          <a:lstStyle/>
+          <a:p>
+            <a:pPr algn="ctr"/>
+          </a:p>
+        </p:txBody>
+      </p:sp>
+      <p:sp>
+        <p:nvSpPr>
+          <p:cNvPr id="28" name="TextBox 27"/>
+          <p:cNvSpPr txBox="1"/>
+          <p:nvPr/>
+        </p:nvSpPr>
+        <p:spPr>
+          <a:xfrm>
+            <a:off x="182880" y="6400800"/>
+            <a:ext cx="5029200" cy="457200"/>
+          </a:xfrm>
+          <a:prstGeom prst="rect">
+            <a:avLst/>
+          </a:prstGeom>
+          <a:noFill/>
+        </p:spPr>
+        <p:txBody>
+          <a:bodyPr wrap="none">
+            <a:spAutoFit/>
+          </a:bodyPr>
+          <a:lstStyle/>
+          <a:p>
+            <a:pPr algn="l"/>
+            <a:r>
+              <a:rPr sz="750" b="0">
+                <a:solidFill>
+                  <a:srgbClr val="B0C4D8"/>
+                </a:solidFill>
+                <a:latin typeface="Calibri"/>
+              </a:rPr>
+              <a:t>auxilab-eval-harness  |  AuxiLab Hackathon 2026</a:t>
+            </a:r>
+          </a:p>
+        </p:txBody>
+      </p:sp>
+      <p:sp>
+        <p:nvSpPr>
+          <p:cNvPr id="29" name="TextBox 28"/>
+          <p:cNvSpPr txBox="1"/>
+          <p:nvPr/>
+        </p:nvSpPr>
+        <p:spPr>
+          <a:xfrm>
+            <a:off x="11091672" y="6400800"/>
+            <a:ext cx="914400" cy="457200"/>
+          </a:xfrm>
+          <a:prstGeom prst="rect">
+            <a:avLst/>
+          </a:prstGeom>
+          <a:noFill/>
+        </p:spPr>
+        <p:txBody>
+          <a:bodyPr wrap="none">
+            <a:spAutoFit/>
+          </a:bodyPr>
+          <a:lstStyle/>
+          <a:p>
+            <a:pPr algn="r"/>
+            <a:r>
+              <a:rPr sz="800" b="1">
+                <a:solidFill>
+                  <a:srgbClr val="00D4FF"/>
+                </a:solidFill>
+                <a:latin typeface="Calibri"/>
+              </a:rPr>
+              <a:t>5  /  6</a:t>
+            </a:r>
+          </a:p>
+        </p:txBody>
+      </p:sp>
+      <p:sp>
+        <p:nvSpPr>
+          <p:cNvPr id="30" name="TextBox 29"/>
+          <p:cNvSpPr txBox="1"/>
+          <p:nvPr/>
+        </p:nvSpPr>
+        <p:spPr>
+          <a:xfrm>
+            <a:off x="9445752" y="6400800"/>
+            <a:ext cx="2468880" cy="457200"/>
+          </a:xfrm>
+          <a:prstGeom prst="rect">
+            <a:avLst/>
+          </a:prstGeom>
+          <a:noFill/>
+        </p:spPr>
+        <p:txBody>
+          <a:bodyPr wrap="none">
+            <a:spAutoFit/>
+          </a:bodyPr>
+          <a:lstStyle/>
+          <a:p>
+            <a:pPr algn="ctr"/>
+            <a:r>
+              <a:rPr sz="650" b="0">
+                <a:solidFill>
+                  <a:srgbClr val="5580A0"/>
+                </a:solidFill>
+                <a:latin typeface="Calibri"/>
+              </a:rPr>
+              <a:t>powered by auxiliobits</a:t>
             </a:r>
           </a:p>
         </p:txBody>
@@ -8110,6 +9830,350 @@
           </a:graphicData>
         </a:graphic>
       </p:graphicFrame>
+      <p:sp>
+        <p:nvSpPr>
+          <p:cNvPr id="13" name="Rectangle 12"/>
+          <p:cNvSpPr/>
+          <p:nvPr/>
+        </p:nvSpPr>
+        <p:spPr>
+          <a:xfrm>
+            <a:off x="9866376" y="51206"/>
+            <a:ext cx="2231136" cy="601675"/>
+          </a:xfrm>
+          <a:prstGeom prst="rect">
+            <a:avLst/>
+          </a:prstGeom>
+          <a:solidFill>
+            <a:srgbClr val="0D1B2A"/>
+          </a:solidFill>
+          <a:ln>
+            <a:noFill/>
+          </a:ln>
+        </p:spPr>
+        <p:style>
+          <a:lnRef idx="1">
+            <a:schemeClr val="accent1"/>
+          </a:lnRef>
+          <a:fillRef idx="3">
+            <a:schemeClr val="accent1"/>
+          </a:fillRef>
+          <a:effectRef idx="2">
+            <a:schemeClr val="accent1"/>
+          </a:effectRef>
+          <a:fontRef idx="minor">
+            <a:schemeClr val="lt1"/>
+          </a:fontRef>
+        </p:style>
+        <p:txBody>
+          <a:bodyPr rtlCol="0" anchor="ctr"/>
+          <a:lstStyle/>
+          <a:p>
+            <a:pPr algn="ctr"/>
+          </a:p>
+        </p:txBody>
+      </p:sp>
+      <p:sp>
+        <p:nvSpPr>
+          <p:cNvPr id="14" name="Rectangle 13"/>
+          <p:cNvSpPr/>
+          <p:nvPr/>
+        </p:nvSpPr>
+        <p:spPr>
+          <a:xfrm>
+            <a:off x="9866376" y="51206"/>
+            <a:ext cx="32004" cy="601675"/>
+          </a:xfrm>
+          <a:prstGeom prst="rect">
+            <a:avLst/>
+          </a:prstGeom>
+          <a:solidFill>
+            <a:srgbClr val="00D4FF"/>
+          </a:solidFill>
+          <a:ln>
+            <a:noFill/>
+          </a:ln>
+        </p:spPr>
+        <p:style>
+          <a:lnRef idx="1">
+            <a:schemeClr val="accent1"/>
+          </a:lnRef>
+          <a:fillRef idx="3">
+            <a:schemeClr val="accent1"/>
+          </a:fillRef>
+          <a:effectRef idx="2">
+            <a:schemeClr val="accent1"/>
+          </a:effectRef>
+          <a:fontRef idx="minor">
+            <a:schemeClr val="lt1"/>
+          </a:fontRef>
+        </p:style>
+        <p:txBody>
+          <a:bodyPr rtlCol="0" anchor="ctr"/>
+          <a:lstStyle/>
+          <a:p>
+            <a:pPr algn="ctr"/>
+          </a:p>
+        </p:txBody>
+      </p:sp>
+      <p:pic>
+        <p:nvPicPr>
+          <p:cNvPr id="15" name="Picture 14" descr="logo_crisp.png"/>
+          <p:cNvPicPr>
+            <a:picLocks noChangeAspect="1"/>
+          </p:cNvPicPr>
+          <p:nvPr/>
+        </p:nvPicPr>
+        <p:blipFill>
+          <a:blip r:embed="rId2"/>
+          <a:stretch>
+            <a:fillRect/>
+          </a:stretch>
+        </p:blipFill>
+        <p:spPr>
+          <a:xfrm>
+            <a:off x="9976103" y="128016"/>
+            <a:ext cx="2011680" cy="448056"/>
+          </a:xfrm>
+          <a:prstGeom prst="rect">
+            <a:avLst/>
+          </a:prstGeom>
+        </p:spPr>
+      </p:pic>
+      <p:sp>
+        <p:nvSpPr>
+          <p:cNvPr id="16" name="Rectangle 15"/>
+          <p:cNvSpPr/>
+          <p:nvPr/>
+        </p:nvSpPr>
+        <p:spPr>
+          <a:xfrm>
+            <a:off x="0" y="6387084"/>
+            <a:ext cx="12188952" cy="13716"/>
+          </a:xfrm>
+          <a:prstGeom prst="rect">
+            <a:avLst/>
+          </a:prstGeom>
+          <a:solidFill>
+            <a:srgbClr val="00D4FF"/>
+          </a:solidFill>
+          <a:ln>
+            <a:noFill/>
+          </a:ln>
+        </p:spPr>
+        <p:style>
+          <a:lnRef idx="1">
+            <a:schemeClr val="accent1"/>
+          </a:lnRef>
+          <a:fillRef idx="3">
+            <a:schemeClr val="accent1"/>
+          </a:fillRef>
+          <a:effectRef idx="2">
+            <a:schemeClr val="accent1"/>
+          </a:effectRef>
+          <a:fontRef idx="minor">
+            <a:schemeClr val="lt1"/>
+          </a:fontRef>
+        </p:style>
+        <p:txBody>
+          <a:bodyPr rtlCol="0" anchor="ctr"/>
+          <a:lstStyle/>
+          <a:p>
+            <a:pPr algn="ctr"/>
+          </a:p>
+        </p:txBody>
+      </p:sp>
+      <p:sp>
+        <p:nvSpPr>
+          <p:cNvPr id="17" name="Rectangle 16"/>
+          <p:cNvSpPr/>
+          <p:nvPr/>
+        </p:nvSpPr>
+        <p:spPr>
+          <a:xfrm>
+            <a:off x="0" y="6400800"/>
+            <a:ext cx="12188952" cy="457200"/>
+          </a:xfrm>
+          <a:prstGeom prst="rect">
+            <a:avLst/>
+          </a:prstGeom>
+          <a:solidFill>
+            <a:srgbClr val="051020"/>
+          </a:solidFill>
+          <a:ln>
+            <a:noFill/>
+          </a:ln>
+        </p:spPr>
+        <p:style>
+          <a:lnRef idx="1">
+            <a:schemeClr val="accent1"/>
+          </a:lnRef>
+          <a:fillRef idx="3">
+            <a:schemeClr val="accent1"/>
+          </a:fillRef>
+          <a:effectRef idx="2">
+            <a:schemeClr val="accent1"/>
+          </a:effectRef>
+          <a:fontRef idx="minor">
+            <a:schemeClr val="lt1"/>
+          </a:fontRef>
+        </p:style>
+        <p:txBody>
+          <a:bodyPr rtlCol="0" anchor="ctr"/>
+          <a:lstStyle/>
+          <a:p>
+            <a:pPr algn="ctr"/>
+          </a:p>
+        </p:txBody>
+      </p:sp>
+      <p:sp>
+        <p:nvSpPr>
+          <p:cNvPr id="18" name="Rectangle 17"/>
+          <p:cNvSpPr/>
+          <p:nvPr/>
+        </p:nvSpPr>
+        <p:spPr>
+          <a:xfrm>
+            <a:off x="0" y="6400800"/>
+            <a:ext cx="45720" cy="457200"/>
+          </a:xfrm>
+          <a:prstGeom prst="rect">
+            <a:avLst/>
+          </a:prstGeom>
+          <a:solidFill>
+            <a:srgbClr val="00D4FF"/>
+          </a:solidFill>
+          <a:ln>
+            <a:noFill/>
+          </a:ln>
+        </p:spPr>
+        <p:style>
+          <a:lnRef idx="1">
+            <a:schemeClr val="accent1"/>
+          </a:lnRef>
+          <a:fillRef idx="3">
+            <a:schemeClr val="accent1"/>
+          </a:fillRef>
+          <a:effectRef idx="2">
+            <a:schemeClr val="accent1"/>
+          </a:effectRef>
+          <a:fontRef idx="minor">
+            <a:schemeClr val="lt1"/>
+          </a:fontRef>
+        </p:style>
+        <p:txBody>
+          <a:bodyPr rtlCol="0" anchor="ctr"/>
+          <a:lstStyle/>
+          <a:p>
+            <a:pPr algn="ctr"/>
+          </a:p>
+        </p:txBody>
+      </p:sp>
+      <p:sp>
+        <p:nvSpPr>
+          <p:cNvPr id="19" name="TextBox 18"/>
+          <p:cNvSpPr txBox="1"/>
+          <p:nvPr/>
+        </p:nvSpPr>
+        <p:spPr>
+          <a:xfrm>
+            <a:off x="182880" y="6400800"/>
+            <a:ext cx="5029200" cy="457200"/>
+          </a:xfrm>
+          <a:prstGeom prst="rect">
+            <a:avLst/>
+          </a:prstGeom>
+          <a:noFill/>
+        </p:spPr>
+        <p:txBody>
+          <a:bodyPr wrap="none">
+            <a:spAutoFit/>
+          </a:bodyPr>
+          <a:lstStyle/>
+          <a:p>
+            <a:pPr algn="l"/>
+            <a:r>
+              <a:rPr sz="750" b="0">
+                <a:solidFill>
+                  <a:srgbClr val="B0C4D8"/>
+                </a:solidFill>
+                <a:latin typeface="Calibri"/>
+              </a:rPr>
+              <a:t>auxilab-eval-harness  |  AuxiLab Hackathon 2026</a:t>
+            </a:r>
+          </a:p>
+        </p:txBody>
+      </p:sp>
+      <p:sp>
+        <p:nvSpPr>
+          <p:cNvPr id="20" name="TextBox 19"/>
+          <p:cNvSpPr txBox="1"/>
+          <p:nvPr/>
+        </p:nvSpPr>
+        <p:spPr>
+          <a:xfrm>
+            <a:off x="11091672" y="6400800"/>
+            <a:ext cx="914400" cy="457200"/>
+          </a:xfrm>
+          <a:prstGeom prst="rect">
+            <a:avLst/>
+          </a:prstGeom>
+          <a:noFill/>
+        </p:spPr>
+        <p:txBody>
+          <a:bodyPr wrap="none">
+            <a:spAutoFit/>
+          </a:bodyPr>
+          <a:lstStyle/>
+          <a:p>
+            <a:pPr algn="r"/>
+            <a:r>
+              <a:rPr sz="800" b="1">
+                <a:solidFill>
+                  <a:srgbClr val="00D4FF"/>
+                </a:solidFill>
+                <a:latin typeface="Calibri"/>
+              </a:rPr>
+              <a:t>6  /  6</a:t>
+            </a:r>
+          </a:p>
+        </p:txBody>
+      </p:sp>
+      <p:sp>
+        <p:nvSpPr>
+          <p:cNvPr id="21" name="TextBox 20"/>
+          <p:cNvSpPr txBox="1"/>
+          <p:nvPr/>
+        </p:nvSpPr>
+        <p:spPr>
+          <a:xfrm>
+            <a:off x="9445752" y="6400800"/>
+            <a:ext cx="2468880" cy="457200"/>
+          </a:xfrm>
+          <a:prstGeom prst="rect">
+            <a:avLst/>
+          </a:prstGeom>
+          <a:noFill/>
+        </p:spPr>
+        <p:txBody>
+          <a:bodyPr wrap="none">
+            <a:spAutoFit/>
+          </a:bodyPr>
+          <a:lstStyle/>
+          <a:p>
+            <a:pPr algn="ctr"/>
+            <a:r>
+              <a:rPr sz="650" b="0">
+                <a:solidFill>
+                  <a:srgbClr val="5580A0"/>
+                </a:solidFill>
+                <a:latin typeface="Calibri"/>
+              </a:rPr>
+              <a:t>powered by auxiliobits</a:t>
+            </a:r>
+          </a:p>
+        </p:txBody>
+      </p:sp>
     </p:spTree>
   </p:cSld>
   <p:clrMapOvr>

</xml_diff>